<commit_message>
Aplica padrão de comunicação (datas DD/MM/AAAA, textos curtos e diretos)
Reformata todas as datas nos entregáveis (planilha, painel, relatório,
apresentação) para DD/MM/AAAA. Reescreve os textos de observação da
aba Análise por Veículo e das Ocorrências no formato Problema → Data →
Situação atual → Ação necessária, removendo linguagem longa/técnica
("período observado", "cobertura de apenas X dia(s)", "indício de
correção conforme regra do estudo"). Renomeia a classificação "Sem
reporte em todo o período observado" para "Sem reporte em todo o
período" e propaga a mudança por planilha, painel, relatório e slides.

Co-Authored-By: Claude Sonnet 5 <noreply@anthropic.com>
Claude-Session: https://claude.ai/code/session_0141CE691yg2zKR9cVjoqoFW
</commit_message>
<xml_diff>
--- a/gestao-combustivel/relatorios/Apresentacao_Diretoria_Combustivel.pptx
+++ b/gestao-combustivel/relatorios/Apresentacao_Diretoria_Combustivel.pptx
@@ -5572,7 +5572,7 @@
                             <a:srgbClr val="000000"/>
                           </a:solidFill>
                         </a:rPr>
-                        <a:t>2026-09-14</a:t>
+                        <a:t>14/09/2026</a:t>
                       </a:r>
                       <a:endParaRPr lang="en-US" sz="1200" dirty="0"/>
                     </a:p>
@@ -5864,7 +5864,7 @@
                             <a:srgbClr val="000000"/>
                           </a:solidFill>
                         </a:rPr>
-                        <a:t>2026-09-14</a:t>
+                        <a:t>14/09/2026</a:t>
                       </a:r>
                       <a:endParaRPr lang="en-US" sz="1200" dirty="0"/>
                     </a:p>
@@ -6156,7 +6156,7 @@
                             <a:srgbClr val="000000"/>
                           </a:solidFill>
                         </a:rPr>
-                        <a:t>2026-09-14</a:t>
+                        <a:t>14/09/2026</a:t>
                       </a:r>
                       <a:endParaRPr lang="en-US" sz="1200" dirty="0"/>
                     </a:p>
@@ -6448,7 +6448,7 @@
                             <a:srgbClr val="000000"/>
                           </a:solidFill>
                         </a:rPr>
-                        <a:t>2026-09-13</a:t>
+                        <a:t>13/09/2026</a:t>
                       </a:r>
                       <a:endParaRPr lang="en-US" sz="1200" dirty="0"/>
                     </a:p>
@@ -6624,7 +6624,7 @@
                             <a:srgbClr val="C0392B"/>
                           </a:solidFill>
                         </a:rPr>
-                        <a:t>Sem reporte em todo o período observado</a:t>
+                        <a:t>Sem reporte em todo o período</a:t>
                       </a:r>
                       <a:endParaRPr lang="en-US" sz="1150" dirty="0"/>
                     </a:p>
@@ -6740,7 +6740,7 @@
                             <a:srgbClr val="000000"/>
                           </a:solidFill>
                         </a:rPr>
-                        <a:t>2026-09-14</a:t>
+                        <a:t>14/09/2026</a:t>
                       </a:r>
                       <a:endParaRPr lang="en-US" sz="1200" dirty="0"/>
                     </a:p>
@@ -6916,7 +6916,7 @@
                             <a:srgbClr val="C0392B"/>
                           </a:solidFill>
                         </a:rPr>
-                        <a:t>Sem reporte em todo o período observado</a:t>
+                        <a:t>Sem reporte em todo o período</a:t>
                       </a:r>
                       <a:endParaRPr lang="en-US" sz="1150" dirty="0"/>
                     </a:p>
@@ -7032,7 +7032,7 @@
                             <a:srgbClr val="000000"/>
                           </a:solidFill>
                         </a:rPr>
-                        <a:t>2026-09-14</a:t>
+                        <a:t>14/09/2026</a:t>
                       </a:r>
                       <a:endParaRPr lang="en-US" sz="1200" dirty="0"/>
                     </a:p>

</xml_diff>